<commit_message>
fixed submit scripts and setup
</commit_message>
<xml_diff>
--- a/day1_material/slides/day1.pptx
+++ b/day1_material/slides/day1.pptx
@@ -220,7 +220,7 @@
           <a:p>
             <a:fld id="{09C84A49-CA76-E84D-B4CB-59BA5B0597A2}" type="datetimeFigureOut">
               <a:rPr lang="en-US" smtClean="0"/>
-              <a:t>9/29/26</a:t>
+              <a:t>9/30/26</a:t>
             </a:fld>
             <a:endParaRPr lang="en-US"/>
           </a:p>
@@ -1526,7 +1526,7 @@
           <a:p>
             <a:fld id="{EC483935-07C3-DB40-BDCF-E55515B19C93}" type="datetimeFigureOut">
               <a:rPr lang="en-US" smtClean="0"/>
-              <a:t>9/29/26</a:t>
+              <a:t>9/30/26</a:t>
             </a:fld>
             <a:endParaRPr lang="en-US"/>
           </a:p>
@@ -1724,7 +1724,7 @@
           <a:p>
             <a:fld id="{EC483935-07C3-DB40-BDCF-E55515B19C93}" type="datetimeFigureOut">
               <a:rPr lang="en-US" smtClean="0"/>
-              <a:t>9/29/26</a:t>
+              <a:t>9/30/26</a:t>
             </a:fld>
             <a:endParaRPr lang="en-US"/>
           </a:p>
@@ -1932,7 +1932,7 @@
           <a:p>
             <a:fld id="{EC483935-07C3-DB40-BDCF-E55515B19C93}" type="datetimeFigureOut">
               <a:rPr lang="en-US" smtClean="0"/>
-              <a:t>9/29/26</a:t>
+              <a:t>9/30/26</a:t>
             </a:fld>
             <a:endParaRPr lang="en-US"/>
           </a:p>
@@ -2130,7 +2130,7 @@
           <a:p>
             <a:fld id="{EC483935-07C3-DB40-BDCF-E55515B19C93}" type="datetimeFigureOut">
               <a:rPr lang="en-US" smtClean="0"/>
-              <a:t>9/29/26</a:t>
+              <a:t>9/30/26</a:t>
             </a:fld>
             <a:endParaRPr lang="en-US"/>
           </a:p>
@@ -2405,7 +2405,7 @@
           <a:p>
             <a:fld id="{EC483935-07C3-DB40-BDCF-E55515B19C93}" type="datetimeFigureOut">
               <a:rPr lang="en-US" smtClean="0"/>
-              <a:t>9/29/26</a:t>
+              <a:t>9/30/26</a:t>
             </a:fld>
             <a:endParaRPr lang="en-US"/>
           </a:p>
@@ -2670,7 +2670,7 @@
           <a:p>
             <a:fld id="{EC483935-07C3-DB40-BDCF-E55515B19C93}" type="datetimeFigureOut">
               <a:rPr lang="en-US" smtClean="0"/>
-              <a:t>9/29/26</a:t>
+              <a:t>9/30/26</a:t>
             </a:fld>
             <a:endParaRPr lang="en-US"/>
           </a:p>
@@ -3082,7 +3082,7 @@
           <a:p>
             <a:fld id="{EC483935-07C3-DB40-BDCF-E55515B19C93}" type="datetimeFigureOut">
               <a:rPr lang="en-US" smtClean="0"/>
-              <a:t>9/29/26</a:t>
+              <a:t>9/30/26</a:t>
             </a:fld>
             <a:endParaRPr lang="en-US"/>
           </a:p>
@@ -3223,7 +3223,7 @@
           <a:p>
             <a:fld id="{EC483935-07C3-DB40-BDCF-E55515B19C93}" type="datetimeFigureOut">
               <a:rPr lang="en-US" smtClean="0"/>
-              <a:t>9/29/26</a:t>
+              <a:t>9/30/26</a:t>
             </a:fld>
             <a:endParaRPr lang="en-US"/>
           </a:p>
@@ -3336,7 +3336,7 @@
           <a:p>
             <a:fld id="{EC483935-07C3-DB40-BDCF-E55515B19C93}" type="datetimeFigureOut">
               <a:rPr lang="en-US" smtClean="0"/>
-              <a:t>9/29/26</a:t>
+              <a:t>9/30/26</a:t>
             </a:fld>
             <a:endParaRPr lang="en-US"/>
           </a:p>
@@ -3647,7 +3647,7 @@
           <a:p>
             <a:fld id="{EC483935-07C3-DB40-BDCF-E55515B19C93}" type="datetimeFigureOut">
               <a:rPr lang="en-US" smtClean="0"/>
-              <a:t>9/29/26</a:t>
+              <a:t>9/30/26</a:t>
             </a:fld>
             <a:endParaRPr lang="en-US"/>
           </a:p>
@@ -3935,7 +3935,7 @@
           <a:p>
             <a:fld id="{EC483935-07C3-DB40-BDCF-E55515B19C93}" type="datetimeFigureOut">
               <a:rPr lang="en-US" smtClean="0"/>
-              <a:t>9/29/26</a:t>
+              <a:t>9/30/26</a:t>
             </a:fld>
             <a:endParaRPr lang="en-US"/>
           </a:p>
@@ -4176,7 +4176,7 @@
           <a:p>
             <a:fld id="{EC483935-07C3-DB40-BDCF-E55515B19C93}" type="datetimeFigureOut">
               <a:rPr lang="en-US" smtClean="0"/>
-              <a:t>9/29/26</a:t>
+              <a:t>9/30/26</a:t>
             </a:fld>
             <a:endParaRPr lang="en-US"/>
           </a:p>
@@ -12815,7 +12815,66 @@
           <a:bodyPr/>
           <a:lstStyle/>
           <a:p>
-            <a:endParaRPr lang="en-US"/>
+            <a:r>
+              <a:rPr lang="en-US" dirty="0"/>
+              <a:t>Code share = </a:t>
+            </a:r>
+            <a:r>
+              <a:rPr lang="en-US" dirty="0" err="1"/>
+              <a:t>github</a:t>
+            </a:r>
+            <a:endParaRPr lang="en-US" dirty="0"/>
+          </a:p>
+          <a:p>
+            <a:r>
+              <a:rPr lang="en-US" dirty="0"/>
+              <a:t>We will use small data files for day1 (</a:t>
+            </a:r>
+            <a:r>
+              <a:rPr lang="en-US" dirty="0" err="1"/>
+              <a:t>github</a:t>
+            </a:r>
+            <a:r>
+              <a:rPr lang="en-US" dirty="0"/>
+              <a:t>) </a:t>
+            </a:r>
+          </a:p>
+          <a:p>
+            <a:r>
+              <a:rPr lang="en-US" dirty="0"/>
+              <a:t>We will use big data files for day2 (hazel) – globus?</a:t>
+            </a:r>
+          </a:p>
+          <a:p>
+            <a:r>
+              <a:rPr lang="en-US" dirty="0"/>
+              <a:t>No internet in compute nodes except xfer (</a:t>
+            </a:r>
+            <a:r>
+              <a:rPr lang="en-US" dirty="0">
+                <a:hlinkClick r:id="rId2"/>
+              </a:rPr>
+              <a:t>https://hurwitzlab.github.io/COS_Compute_Handbook/chapters/10_downloading_data.html</a:t>
+            </a:r>
+            <a:r>
+              <a:rPr lang="en-US" dirty="0"/>
+              <a:t>) </a:t>
+            </a:r>
+          </a:p>
+          <a:p>
+            <a:r>
+              <a:rPr lang="en-US" dirty="0"/>
+              <a:t>BRC modules are wrapped container images</a:t>
+            </a:r>
+          </a:p>
+          <a:p>
+            <a:r>
+              <a:rPr lang="en-US" dirty="0"/>
+              <a:t>Jobs my take a while to run, we normally don’t need to wait, it is more important to understand what we are doing and why</a:t>
+            </a:r>
+          </a:p>
+          <a:p>
+            <a:endParaRPr lang="en-US" dirty="0"/>
           </a:p>
         </p:txBody>
       </p:sp>

</xml_diff>

<commit_message>
fixes quarto and site
Added a next steps
Added a navbar
Fixed quarto day 1 callout
</commit_message>
<xml_diff>
--- a/day1_material/slides/day1.pptx
+++ b/day1_material/slides/day1.pptx
@@ -5,7 +5,7 @@
     <p:sldMasterId id="2147483648" r:id="rId1"/>
   </p:sldMasterIdLst>
   <p:notesMasterIdLst>
-    <p:notesMasterId r:id="rId26"/>
+    <p:notesMasterId r:id="rId28"/>
   </p:notesMasterIdLst>
   <p:sldIdLst>
     <p:sldId id="256" r:id="rId2"/>
@@ -32,6 +32,8 @@
     <p:sldId id="303" r:id="rId23"/>
     <p:sldId id="305" r:id="rId24"/>
     <p:sldId id="309" r:id="rId25"/>
+    <p:sldId id="311" r:id="rId26"/>
+    <p:sldId id="310" r:id="rId27"/>
   </p:sldIdLst>
   <p:sldSz cx="12192000" cy="6858000"/>
   <p:notesSz cx="6858000" cy="9144000"/>
@@ -220,7 +222,7 @@
           <a:p>
             <a:fld id="{09C84A49-CA76-E84D-B4CB-59BA5B0597A2}" type="datetimeFigureOut">
               <a:rPr lang="en-US" smtClean="0"/>
-              <a:t>9/30/26</a:t>
+              <a:t>10/2/26</a:t>
             </a:fld>
             <a:endParaRPr lang="en-US"/>
           </a:p>
@@ -1526,7 +1528,7 @@
           <a:p>
             <a:fld id="{EC483935-07C3-DB40-BDCF-E55515B19C93}" type="datetimeFigureOut">
               <a:rPr lang="en-US" smtClean="0"/>
-              <a:t>9/30/26</a:t>
+              <a:t>10/2/26</a:t>
             </a:fld>
             <a:endParaRPr lang="en-US"/>
           </a:p>
@@ -1724,7 +1726,7 @@
           <a:p>
             <a:fld id="{EC483935-07C3-DB40-BDCF-E55515B19C93}" type="datetimeFigureOut">
               <a:rPr lang="en-US" smtClean="0"/>
-              <a:t>9/30/26</a:t>
+              <a:t>10/2/26</a:t>
             </a:fld>
             <a:endParaRPr lang="en-US"/>
           </a:p>
@@ -1932,7 +1934,7 @@
           <a:p>
             <a:fld id="{EC483935-07C3-DB40-BDCF-E55515B19C93}" type="datetimeFigureOut">
               <a:rPr lang="en-US" smtClean="0"/>
-              <a:t>9/30/26</a:t>
+              <a:t>10/2/26</a:t>
             </a:fld>
             <a:endParaRPr lang="en-US"/>
           </a:p>
@@ -2130,7 +2132,7 @@
           <a:p>
             <a:fld id="{EC483935-07C3-DB40-BDCF-E55515B19C93}" type="datetimeFigureOut">
               <a:rPr lang="en-US" smtClean="0"/>
-              <a:t>9/30/26</a:t>
+              <a:t>10/2/26</a:t>
             </a:fld>
             <a:endParaRPr lang="en-US"/>
           </a:p>
@@ -2405,7 +2407,7 @@
           <a:p>
             <a:fld id="{EC483935-07C3-DB40-BDCF-E55515B19C93}" type="datetimeFigureOut">
               <a:rPr lang="en-US" smtClean="0"/>
-              <a:t>9/30/26</a:t>
+              <a:t>10/2/26</a:t>
             </a:fld>
             <a:endParaRPr lang="en-US"/>
           </a:p>
@@ -2670,7 +2672,7 @@
           <a:p>
             <a:fld id="{EC483935-07C3-DB40-BDCF-E55515B19C93}" type="datetimeFigureOut">
               <a:rPr lang="en-US" smtClean="0"/>
-              <a:t>9/30/26</a:t>
+              <a:t>10/2/26</a:t>
             </a:fld>
             <a:endParaRPr lang="en-US"/>
           </a:p>
@@ -3082,7 +3084,7 @@
           <a:p>
             <a:fld id="{EC483935-07C3-DB40-BDCF-E55515B19C93}" type="datetimeFigureOut">
               <a:rPr lang="en-US" smtClean="0"/>
-              <a:t>9/30/26</a:t>
+              <a:t>10/2/26</a:t>
             </a:fld>
             <a:endParaRPr lang="en-US"/>
           </a:p>
@@ -3223,7 +3225,7 @@
           <a:p>
             <a:fld id="{EC483935-07C3-DB40-BDCF-E55515B19C93}" type="datetimeFigureOut">
               <a:rPr lang="en-US" smtClean="0"/>
-              <a:t>9/30/26</a:t>
+              <a:t>10/2/26</a:t>
             </a:fld>
             <a:endParaRPr lang="en-US"/>
           </a:p>
@@ -3336,7 +3338,7 @@
           <a:p>
             <a:fld id="{EC483935-07C3-DB40-BDCF-E55515B19C93}" type="datetimeFigureOut">
               <a:rPr lang="en-US" smtClean="0"/>
-              <a:t>9/30/26</a:t>
+              <a:t>10/2/26</a:t>
             </a:fld>
             <a:endParaRPr lang="en-US"/>
           </a:p>
@@ -3647,7 +3649,7 @@
           <a:p>
             <a:fld id="{EC483935-07C3-DB40-BDCF-E55515B19C93}" type="datetimeFigureOut">
               <a:rPr lang="en-US" smtClean="0"/>
-              <a:t>9/30/26</a:t>
+              <a:t>10/2/26</a:t>
             </a:fld>
             <a:endParaRPr lang="en-US"/>
           </a:p>
@@ -3935,7 +3937,7 @@
           <a:p>
             <a:fld id="{EC483935-07C3-DB40-BDCF-E55515B19C93}" type="datetimeFigureOut">
               <a:rPr lang="en-US" smtClean="0"/>
-              <a:t>9/30/26</a:t>
+              <a:t>10/2/26</a:t>
             </a:fld>
             <a:endParaRPr lang="en-US"/>
           </a:p>
@@ -4176,7 +4178,7 @@
           <a:p>
             <a:fld id="{EC483935-07C3-DB40-BDCF-E55515B19C93}" type="datetimeFigureOut">
               <a:rPr lang="en-US" smtClean="0"/>
-              <a:t>9/30/26</a:t>
+              <a:t>10/2/26</a:t>
             </a:fld>
             <a:endParaRPr lang="en-US"/>
           </a:p>
@@ -12734,6 +12736,261 @@
     <p:extLst>
       <p:ext uri="{BB962C8B-B14F-4D97-AF65-F5344CB8AC3E}">
         <p14:creationId xmlns:p14="http://schemas.microsoft.com/office/powerpoint/2010/main" val="493050639"/>
+      </p:ext>
+    </p:extLst>
+  </p:cSld>
+  <p:clrMapOvr>
+    <a:masterClrMapping/>
+  </p:clrMapOvr>
+</p:sld>
+</file>
+
+<file path=ppt/slides/slide25.xml><?xml version="1.0" encoding="utf-8"?>
+<p:sld xmlns:a="http://schemas.openxmlformats.org/drawingml/2006/main" xmlns:r="http://schemas.openxmlformats.org/officeDocument/2006/relationships" xmlns:p="http://schemas.openxmlformats.org/presentationml/2006/main">
+  <p:cSld>
+    <p:spTree>
+      <p:nvGrpSpPr>
+        <p:cNvPr id="1" name=""/>
+        <p:cNvGrpSpPr/>
+        <p:nvPr/>
+      </p:nvGrpSpPr>
+      <p:grpSpPr>
+        <a:xfrm>
+          <a:off x="0" y="0"/>
+          <a:ext cx="0" cy="0"/>
+          <a:chOff x="0" y="0"/>
+          <a:chExt cx="0" cy="0"/>
+        </a:xfrm>
+      </p:grpSpPr>
+      <p:sp>
+        <p:nvSpPr>
+          <p:cNvPr id="4" name="Title 1">
+            <a:extLst>
+              <a:ext uri="{FF2B5EF4-FFF2-40B4-BE49-F238E27FC236}">
+                <a16:creationId xmlns:a16="http://schemas.microsoft.com/office/drawing/2014/main" id="{C95ACD5E-A6FD-711E-3B35-DB8A4D17DC48}"/>
+              </a:ext>
+            </a:extLst>
+          </p:cNvPr>
+          <p:cNvSpPr>
+            <a:spLocks noGrp="1"/>
+          </p:cNvSpPr>
+          <p:nvPr>
+            <p:ph type="title"/>
+          </p:nvPr>
+        </p:nvSpPr>
+        <p:spPr>
+          <a:xfrm>
+            <a:off x="838200" y="365125"/>
+            <a:ext cx="10515600" cy="1325563"/>
+          </a:xfrm>
+        </p:spPr>
+        <p:txBody>
+          <a:bodyPr>
+            <a:normAutofit/>
+          </a:bodyPr>
+          <a:lstStyle/>
+          <a:p>
+            <a:r>
+              <a:rPr lang="en-US" sz="4000" dirty="0">
+                <a:latin typeface="Helvetica" pitchFamily="2" charset="0"/>
+              </a:rPr>
+              <a:t>Next steps…</a:t>
+            </a:r>
+          </a:p>
+        </p:txBody>
+      </p:sp>
+      <p:pic>
+        <p:nvPicPr>
+          <p:cNvPr id="7" name="Picture 6" descr="nf-core">
+            <a:extLst>
+              <a:ext uri="{FF2B5EF4-FFF2-40B4-BE49-F238E27FC236}">
+                <a16:creationId xmlns:a16="http://schemas.microsoft.com/office/drawing/2014/main" id="{03BE56AD-44DB-1207-F500-4D23226699E3}"/>
+              </a:ext>
+            </a:extLst>
+          </p:cNvPr>
+          <p:cNvPicPr>
+            <a:picLocks noChangeAspect="1"/>
+          </p:cNvPicPr>
+          <p:nvPr/>
+        </p:nvPicPr>
+        <p:blipFill>
+          <a:blip r:embed="rId2"/>
+          <a:stretch>
+            <a:fillRect/>
+          </a:stretch>
+        </p:blipFill>
+        <p:spPr>
+          <a:xfrm>
+            <a:off x="838200" y="2380555"/>
+            <a:ext cx="5424080" cy="3051046"/>
+          </a:xfrm>
+          <a:prstGeom prst="rect">
+            <a:avLst/>
+          </a:prstGeom>
+        </p:spPr>
+      </p:pic>
+      <p:pic>
+        <p:nvPicPr>
+          <p:cNvPr id="8" name="Picture 7" descr="A simple test framework for Nextflow pipelines - Askimed">
+            <a:extLst>
+              <a:ext uri="{FF2B5EF4-FFF2-40B4-BE49-F238E27FC236}">
+                <a16:creationId xmlns:a16="http://schemas.microsoft.com/office/drawing/2014/main" id="{675C2A6E-24A6-B974-5E74-524567E856D0}"/>
+              </a:ext>
+            </a:extLst>
+          </p:cNvPr>
+          <p:cNvPicPr>
+            <a:picLocks noChangeAspect="1"/>
+          </p:cNvPicPr>
+          <p:nvPr/>
+        </p:nvPicPr>
+        <p:blipFill>
+          <a:blip r:embed="rId3"/>
+          <a:stretch>
+            <a:fillRect/>
+          </a:stretch>
+        </p:blipFill>
+        <p:spPr>
+          <a:xfrm>
+            <a:off x="6742669" y="1431235"/>
+            <a:ext cx="5049079" cy="4488070"/>
+          </a:xfrm>
+          <a:prstGeom prst="rect">
+            <a:avLst/>
+          </a:prstGeom>
+        </p:spPr>
+      </p:pic>
+    </p:spTree>
+    <p:extLst>
+      <p:ext uri="{BB962C8B-B14F-4D97-AF65-F5344CB8AC3E}">
+        <p14:creationId xmlns:p14="http://schemas.microsoft.com/office/powerpoint/2010/main" val="3539972613"/>
+      </p:ext>
+    </p:extLst>
+  </p:cSld>
+  <p:clrMapOvr>
+    <a:masterClrMapping/>
+  </p:clrMapOvr>
+</p:sld>
+</file>
+
+<file path=ppt/slides/slide26.xml><?xml version="1.0" encoding="utf-8"?>
+<p:sld xmlns:a="http://schemas.openxmlformats.org/drawingml/2006/main" xmlns:r="http://schemas.openxmlformats.org/officeDocument/2006/relationships" xmlns:p="http://schemas.openxmlformats.org/presentationml/2006/main">
+  <p:cSld>
+    <p:spTree>
+      <p:nvGrpSpPr>
+        <p:cNvPr id="1" name=""/>
+        <p:cNvGrpSpPr/>
+        <p:nvPr/>
+      </p:nvGrpSpPr>
+      <p:grpSpPr>
+        <a:xfrm>
+          <a:off x="0" y="0"/>
+          <a:ext cx="0" cy="0"/>
+          <a:chOff x="0" y="0"/>
+          <a:chExt cx="0" cy="0"/>
+        </a:xfrm>
+      </p:grpSpPr>
+      <p:pic>
+        <p:nvPicPr>
+          <p:cNvPr id="4" name="Picture 3">
+            <a:extLst>
+              <a:ext uri="{FF2B5EF4-FFF2-40B4-BE49-F238E27FC236}">
+                <a16:creationId xmlns:a16="http://schemas.microsoft.com/office/drawing/2014/main" id="{304F6AEA-5F69-088A-A0DE-40B32ABDE5AB}"/>
+              </a:ext>
+            </a:extLst>
+          </p:cNvPr>
+          <p:cNvPicPr>
+            <a:picLocks noChangeAspect="1"/>
+          </p:cNvPicPr>
+          <p:nvPr/>
+        </p:nvPicPr>
+        <p:blipFill>
+          <a:blip r:embed="rId2"/>
+          <a:srcRect t="3724"/>
+          <a:stretch>
+            <a:fillRect/>
+          </a:stretch>
+        </p:blipFill>
+        <p:spPr>
+          <a:xfrm>
+            <a:off x="6851374" y="1690688"/>
+            <a:ext cx="4784312" cy="4523409"/>
+          </a:xfrm>
+          <a:prstGeom prst="rect">
+            <a:avLst/>
+          </a:prstGeom>
+        </p:spPr>
+      </p:pic>
+      <p:sp>
+        <p:nvSpPr>
+          <p:cNvPr id="6" name="Title 1">
+            <a:extLst>
+              <a:ext uri="{FF2B5EF4-FFF2-40B4-BE49-F238E27FC236}">
+                <a16:creationId xmlns:a16="http://schemas.microsoft.com/office/drawing/2014/main" id="{8890979E-372F-41F4-5A62-CEF5E67B65ED}"/>
+              </a:ext>
+            </a:extLst>
+          </p:cNvPr>
+          <p:cNvSpPr>
+            <a:spLocks noGrp="1"/>
+          </p:cNvSpPr>
+          <p:nvPr>
+            <p:ph type="title"/>
+          </p:nvPr>
+        </p:nvSpPr>
+        <p:spPr>
+          <a:xfrm>
+            <a:off x="838200" y="365125"/>
+            <a:ext cx="10515600" cy="1325563"/>
+          </a:xfrm>
+        </p:spPr>
+        <p:txBody>
+          <a:bodyPr>
+            <a:normAutofit/>
+          </a:bodyPr>
+          <a:lstStyle/>
+          <a:p>
+            <a:r>
+              <a:rPr lang="en-US" sz="4000" dirty="0">
+                <a:latin typeface="Helvetica" pitchFamily="2" charset="0"/>
+              </a:rPr>
+              <a:t>Leave us your feedback!</a:t>
+            </a:r>
+          </a:p>
+        </p:txBody>
+      </p:sp>
+      <p:pic>
+        <p:nvPicPr>
+          <p:cNvPr id="7" name="Picture 6" descr="Feedback - Free icons">
+            <a:extLst>
+              <a:ext uri="{FF2B5EF4-FFF2-40B4-BE49-F238E27FC236}">
+                <a16:creationId xmlns:a16="http://schemas.microsoft.com/office/drawing/2014/main" id="{020CDB47-E032-4988-06C4-FF412787737F}"/>
+              </a:ext>
+            </a:extLst>
+          </p:cNvPr>
+          <p:cNvPicPr>
+            <a:picLocks noChangeAspect="1"/>
+          </p:cNvPicPr>
+          <p:nvPr/>
+        </p:nvPicPr>
+        <p:blipFill>
+          <a:blip r:embed="rId3"/>
+          <a:stretch>
+            <a:fillRect/>
+          </a:stretch>
+        </p:blipFill>
+        <p:spPr>
+          <a:xfrm>
+            <a:off x="1510471" y="3429000"/>
+            <a:ext cx="3429000" cy="3429000"/>
+          </a:xfrm>
+          <a:prstGeom prst="rect">
+            <a:avLst/>
+          </a:prstGeom>
+        </p:spPr>
+      </p:pic>
+    </p:spTree>
+    <p:extLst>
+      <p:ext uri="{BB962C8B-B14F-4D97-AF65-F5344CB8AC3E}">
+        <p14:creationId xmlns:p14="http://schemas.microsoft.com/office/powerpoint/2010/main" val="3239728250"/>
       </p:ext>
     </p:extLst>
   </p:cSld>

</xml_diff>